<commit_message>
Rebuild ATV slide as native pptx shapes (fully editable)
Replaced embedded PNG with native pptxgenjs text boxes and shapes
so all elements are editable directly in PowerPoint.

Co-Authored-By: Claude Sonnet 4.6 <noreply@anthropic.com>
Claude-Session: https://claude.ai/code/session_0178o7F12XYkrs68ukbrnB6m
</commit_message>
<xml_diff>
--- a/GMS_Oakberry_ATV_Slide.pptx
+++ b/GMS_Oakberry_ATV_Slide.pptx
@@ -914,30 +914,679 @@
           </a:p>
         </p:txBody>
       </p:sp>
-      <p:pic>
-        <p:nvPicPr>
-          <p:cNvPr id="3" name="Image 0" descr="/home/user/dashbaord/atv_graphic.png">    </p:cNvPr>
-          <p:cNvPicPr>
-            <a:picLocks noChangeAspect="1"/>
-          </p:cNvPicPr>
+      <p:sp>
+        <p:nvSpPr>
+          <p:cNvPr id="3" name="Text 1"/>
+          <p:cNvSpPr txBox="1"/>
           <p:nvPr/>
-        </p:nvPicPr>
-        <p:blipFill>
-          <a:blip r:embed="rId1"/>
-          <a:stretch>
-            <a:fillRect/>
-          </a:stretch>
-        </p:blipFill>
-        <p:spPr>
-          <a:xfrm>
-            <a:off x="457200" y="274320"/>
-            <a:ext cx="11277295" cy="6309360"/>
-          </a:xfrm>
-          <a:prstGeom prst="rect">
-            <a:avLst/>
-          </a:prstGeom>
-        </p:spPr>
-      </p:pic>
+        </p:nvSpPr>
+        <p:spPr>
+          <a:xfrm>
+            <a:off x="457200" y="201168"/>
+            <a:ext cx="3657600" cy="237744"/>
+          </a:xfrm>
+          <a:prstGeom prst="rect">
+            <a:avLst/>
+          </a:prstGeom>
+          <a:noFill/>
+          <a:ln/>
+        </p:spPr>
+        <p:txBody>
+          <a:bodyPr wrap="square" lIns="0" tIns="0" rIns="0" bIns="0" rtlCol="0" anchor="ctr"/>
+          <a:lstStyle/>
+          <a:p>
+            <a:pPr indent="0" marL="0">
+              <a:buNone/>
+            </a:pPr>
+            <a:r>
+              <a:rPr lang="en-US" sz="1000" b="1" spc="150" kern="0" dirty="0">
+                <a:solidFill>
+                  <a:srgbClr val="E8541C"/>
+                </a:solidFill>
+                <a:latin typeface="Poppins" pitchFamily="34" charset="0"/>
+                <a:ea typeface="Poppins" pitchFamily="34" charset="-122"/>
+                <a:cs typeface="Poppins" pitchFamily="34" charset="-120"/>
+              </a:rPr>
+              <a:t>SECTION 04</a:t>
+            </a:r>
+            <a:endParaRPr lang="en-US" sz="1000" dirty="0"/>
+          </a:p>
+        </p:txBody>
+      </p:sp>
+      <p:sp>
+        <p:nvSpPr>
+          <p:cNvPr id="4" name="Text 2"/>
+          <p:cNvSpPr txBox="1"/>
+          <p:nvPr/>
+        </p:nvSpPr>
+        <p:spPr>
+          <a:xfrm>
+            <a:off x="457200" y="502920"/>
+            <a:ext cx="10972800" cy="1097280"/>
+          </a:xfrm>
+          <a:prstGeom prst="rect">
+            <a:avLst/>
+          </a:prstGeom>
+          <a:noFill/>
+          <a:ln/>
+        </p:spPr>
+        <p:txBody>
+          <a:bodyPr wrap="square" lIns="0" tIns="0" rIns="0" bIns="0" rtlCol="0" anchor="ctr"/>
+          <a:lstStyle/>
+          <a:p>
+            <a:pPr indent="0" marL="0">
+              <a:lnSpc>
+                <a:spcPct val="105000"/>
+              </a:lnSpc>
+              <a:buNone/>
+            </a:pPr>
+            <a:r>
+              <a:rPr lang="en-US" sz="4200" b="1" dirty="0">
+                <a:solidFill>
+                  <a:srgbClr val="FFFFFF"/>
+                </a:solidFill>
+                <a:latin typeface="Poppins" pitchFamily="34" charset="0"/>
+                <a:ea typeface="Poppins" pitchFamily="34" charset="-122"/>
+                <a:cs typeface="Poppins" pitchFamily="34" charset="-120"/>
+              </a:rPr>
+              <a:t>ADS DRIVE VOLUME,</a:t>
+            </a:r>
+            <a:endParaRPr lang="en-US" sz="4200" dirty="0"/>
+          </a:p>
+          <a:p>
+            <a:pPr indent="0" marL="0">
+              <a:lnSpc>
+                <a:spcPct val="105000"/>
+              </a:lnSpc>
+              <a:buNone/>
+            </a:pPr>
+            <a:r>
+              <a:rPr lang="en-US" sz="4200" b="1" dirty="0">
+                <a:solidFill>
+                  <a:srgbClr val="FFFFFF"/>
+                </a:solidFill>
+                <a:latin typeface="Poppins" pitchFamily="34" charset="0"/>
+                <a:ea typeface="Poppins" pitchFamily="34" charset="-122"/>
+                <a:cs typeface="Poppins" pitchFamily="34" charset="-120"/>
+              </a:rPr>
+              <a:t>NOT SPEND SIZE.</a:t>
+            </a:r>
+            <a:endParaRPr lang="en-US" sz="4200" dirty="0"/>
+          </a:p>
+        </p:txBody>
+      </p:sp>
+      <p:sp>
+        <p:nvSpPr>
+          <p:cNvPr id="5" name="Shape 3"/>
+          <p:cNvSpPr/>
+          <p:nvPr/>
+        </p:nvSpPr>
+        <p:spPr>
+          <a:xfrm>
+            <a:off x="457200" y="1737360"/>
+            <a:ext cx="11247120" cy="36576"/>
+          </a:xfrm>
+          <a:prstGeom prst="rect">
+            <a:avLst/>
+          </a:prstGeom>
+          <a:solidFill>
+            <a:srgbClr val="1E3A55"/>
+          </a:solidFill>
+          <a:ln w="12700">
+            <a:solidFill>
+              <a:srgbClr val="1E3A55"/>
+            </a:solidFill>
+            <a:prstDash val="solid"/>
+          </a:ln>
+        </p:spPr>
+      </p:sp>
+      <p:sp>
+        <p:nvSpPr>
+          <p:cNvPr id="6" name="Shape 4"/>
+          <p:cNvSpPr/>
+          <p:nvPr/>
+        </p:nvSpPr>
+        <p:spPr>
+          <a:xfrm>
+            <a:off x="502920" y="1920240"/>
+            <a:ext cx="5029200" cy="3657600"/>
+          </a:xfrm>
+          <a:prstGeom prst="roundRect">
+            <a:avLst>
+              <a:gd name="adj" fmla="val 3000"/>
+            </a:avLst>
+          </a:prstGeom>
+          <a:solidFill>
+            <a:srgbClr val="0F2236"/>
+          </a:solidFill>
+          <a:ln w="12700">
+            <a:solidFill>
+              <a:srgbClr val="0F2236"/>
+            </a:solidFill>
+            <a:prstDash val="solid"/>
+          </a:ln>
+        </p:spPr>
+      </p:sp>
+      <p:sp>
+        <p:nvSpPr>
+          <p:cNvPr id="7" name="Text 5"/>
+          <p:cNvSpPr txBox="1"/>
+          <p:nvPr/>
+        </p:nvSpPr>
+        <p:spPr>
+          <a:xfrm>
+            <a:off x="502920" y="2176272"/>
+            <a:ext cx="5029200" cy="274320"/>
+          </a:xfrm>
+          <a:prstGeom prst="rect">
+            <a:avLst/>
+          </a:prstGeom>
+          <a:noFill/>
+          <a:ln/>
+        </p:spPr>
+        <p:txBody>
+          <a:bodyPr wrap="square" lIns="0" tIns="0" rIns="0" bIns="0" rtlCol="0" anchor="ctr"/>
+          <a:lstStyle/>
+          <a:p>
+            <a:pPr algn="ctr" indent="0" marL="0">
+              <a:buNone/>
+            </a:pPr>
+            <a:r>
+              <a:rPr lang="en-US" sz="1200" b="1" dirty="0">
+                <a:solidFill>
+                  <a:srgbClr val="7A8FA8"/>
+                </a:solidFill>
+                <a:latin typeface="Poppins" pitchFamily="34" charset="0"/>
+                <a:ea typeface="Poppins" pitchFamily="34" charset="-122"/>
+                <a:cs typeface="Poppins" pitchFamily="34" charset="-120"/>
+              </a:rPr>
+              <a:t>AD-EXPOSED</a:t>
+            </a:r>
+            <a:endParaRPr lang="en-US" sz="1200" dirty="0"/>
+          </a:p>
+        </p:txBody>
+      </p:sp>
+      <p:sp>
+        <p:nvSpPr>
+          <p:cNvPr id="8" name="Text 6"/>
+          <p:cNvSpPr txBox="1"/>
+          <p:nvPr/>
+        </p:nvSpPr>
+        <p:spPr>
+          <a:xfrm>
+            <a:off x="502920" y="2606040"/>
+            <a:ext cx="5029200" cy="1188720"/>
+          </a:xfrm>
+          <a:prstGeom prst="rect">
+            <a:avLst/>
+          </a:prstGeom>
+          <a:noFill/>
+          <a:ln/>
+        </p:spPr>
+        <p:txBody>
+          <a:bodyPr wrap="square" lIns="0" tIns="0" rIns="0" bIns="0" rtlCol="0" anchor="ctr"/>
+          <a:lstStyle/>
+          <a:p>
+            <a:pPr algn="ctr" indent="0" marL="0">
+              <a:buNone/>
+            </a:pPr>
+            <a:r>
+              <a:rPr lang="en-US" sz="7200" b="1" dirty="0">
+                <a:solidFill>
+                  <a:srgbClr val="FFFFFF"/>
+                </a:solidFill>
+                <a:latin typeface="Poppins" pitchFamily="34" charset="0"/>
+                <a:ea typeface="Poppins" pitchFamily="34" charset="-122"/>
+                <a:cs typeface="Poppins" pitchFamily="34" charset="-120"/>
+              </a:rPr>
+              <a:t>$28.67</a:t>
+            </a:r>
+            <a:endParaRPr lang="en-US" sz="7200" dirty="0"/>
+          </a:p>
+        </p:txBody>
+      </p:sp>
+      <p:sp>
+        <p:nvSpPr>
+          <p:cNvPr id="9" name="Text 7"/>
+          <p:cNvSpPr txBox="1"/>
+          <p:nvPr/>
+        </p:nvSpPr>
+        <p:spPr>
+          <a:xfrm>
+            <a:off x="502920" y="3886200"/>
+            <a:ext cx="5029200" cy="274320"/>
+          </a:xfrm>
+          <a:prstGeom prst="rect">
+            <a:avLst/>
+          </a:prstGeom>
+          <a:noFill/>
+          <a:ln/>
+        </p:spPr>
+        <p:txBody>
+          <a:bodyPr wrap="square" lIns="0" tIns="0" rIns="0" bIns="0" rtlCol="0" anchor="ctr"/>
+          <a:lstStyle/>
+          <a:p>
+            <a:pPr algn="ctr" indent="0" marL="0">
+              <a:buNone/>
+            </a:pPr>
+            <a:r>
+              <a:rPr lang="en-US" sz="1000" dirty="0">
+                <a:solidFill>
+                  <a:srgbClr val="7A8FA8"/>
+                </a:solidFill>
+                <a:latin typeface="Poppins" pitchFamily="34" charset="0"/>
+                <a:ea typeface="Poppins" pitchFamily="34" charset="-122"/>
+                <a:cs typeface="Poppins" pitchFamily="34" charset="-120"/>
+              </a:rPr>
+              <a:t>AVERAGE TRANSACTION VALUE</a:t>
+            </a:r>
+            <a:endParaRPr lang="en-US" sz="1000" dirty="0"/>
+          </a:p>
+        </p:txBody>
+      </p:sp>
+      <p:sp>
+        <p:nvSpPr>
+          <p:cNvPr id="10" name="Text 8"/>
+          <p:cNvSpPr txBox="1"/>
+          <p:nvPr/>
+        </p:nvSpPr>
+        <p:spPr>
+          <a:xfrm>
+            <a:off x="502920" y="4251960"/>
+            <a:ext cx="5029200" cy="256032"/>
+          </a:xfrm>
+          <a:prstGeom prst="rect">
+            <a:avLst/>
+          </a:prstGeom>
+          <a:noFill/>
+          <a:ln/>
+        </p:spPr>
+        <p:txBody>
+          <a:bodyPr wrap="square" lIns="0" tIns="0" rIns="0" bIns="0" rtlCol="0" anchor="ctr"/>
+          <a:lstStyle/>
+          <a:p>
+            <a:pPr algn="ctr" indent="0" marL="0">
+              <a:buNone/>
+            </a:pPr>
+            <a:r>
+              <a:rPr lang="en-US" sz="1000" b="1" dirty="0">
+                <a:solidFill>
+                  <a:srgbClr val="E8541C"/>
+                </a:solidFill>
+                <a:latin typeface="Poppins" pitchFamily="34" charset="0"/>
+                <a:ea typeface="Poppins" pitchFamily="34" charset="-122"/>
+                <a:cs typeface="Poppins" pitchFamily="34" charset="-120"/>
+              </a:rPr>
+              <a:t>AUGUST 2026</a:t>
+            </a:r>
+            <a:endParaRPr lang="en-US" sz="1000" dirty="0"/>
+          </a:p>
+        </p:txBody>
+      </p:sp>
+      <p:sp>
+        <p:nvSpPr>
+          <p:cNvPr id="11" name="Shape 9"/>
+          <p:cNvSpPr/>
+          <p:nvPr/>
+        </p:nvSpPr>
+        <p:spPr>
+          <a:xfrm>
+            <a:off x="6656832" y="1920240"/>
+            <a:ext cx="5029200" cy="3657600"/>
+          </a:xfrm>
+          <a:prstGeom prst="roundRect">
+            <a:avLst>
+              <a:gd name="adj" fmla="val 3000"/>
+            </a:avLst>
+          </a:prstGeom>
+          <a:solidFill>
+            <a:srgbClr val="0F2236"/>
+          </a:solidFill>
+          <a:ln w="12700">
+            <a:solidFill>
+              <a:srgbClr val="0F2236"/>
+            </a:solidFill>
+            <a:prstDash val="solid"/>
+          </a:ln>
+        </p:spPr>
+      </p:sp>
+      <p:sp>
+        <p:nvSpPr>
+          <p:cNvPr id="12" name="Text 10"/>
+          <p:cNvSpPr txBox="1"/>
+          <p:nvPr/>
+        </p:nvSpPr>
+        <p:spPr>
+          <a:xfrm>
+            <a:off x="6656832" y="2176272"/>
+            <a:ext cx="5029200" cy="274320"/>
+          </a:xfrm>
+          <a:prstGeom prst="rect">
+            <a:avLst/>
+          </a:prstGeom>
+          <a:noFill/>
+          <a:ln/>
+        </p:spPr>
+        <p:txBody>
+          <a:bodyPr wrap="square" lIns="0" tIns="0" rIns="0" bIns="0" rtlCol="0" anchor="ctr"/>
+          <a:lstStyle/>
+          <a:p>
+            <a:pPr algn="ctr" indent="0" marL="0">
+              <a:buNone/>
+            </a:pPr>
+            <a:r>
+              <a:rPr lang="en-US" sz="1200" b="1" dirty="0">
+                <a:solidFill>
+                  <a:srgbClr val="7A8FA8"/>
+                </a:solidFill>
+                <a:latin typeface="Poppins" pitchFamily="34" charset="0"/>
+                <a:ea typeface="Poppins" pitchFamily="34" charset="-122"/>
+                <a:cs typeface="Poppins" pitchFamily="34" charset="-120"/>
+              </a:rPr>
+              <a:t>HOLDOUT GROUP</a:t>
+            </a:r>
+            <a:endParaRPr lang="en-US" sz="1200" dirty="0"/>
+          </a:p>
+        </p:txBody>
+      </p:sp>
+      <p:sp>
+        <p:nvSpPr>
+          <p:cNvPr id="13" name="Text 11"/>
+          <p:cNvSpPr txBox="1"/>
+          <p:nvPr/>
+        </p:nvSpPr>
+        <p:spPr>
+          <a:xfrm>
+            <a:off x="6656832" y="2606040"/>
+            <a:ext cx="5029200" cy="1188720"/>
+          </a:xfrm>
+          <a:prstGeom prst="rect">
+            <a:avLst/>
+          </a:prstGeom>
+          <a:noFill/>
+          <a:ln/>
+        </p:spPr>
+        <p:txBody>
+          <a:bodyPr wrap="square" lIns="0" tIns="0" rIns="0" bIns="0" rtlCol="0" anchor="ctr"/>
+          <a:lstStyle/>
+          <a:p>
+            <a:pPr algn="ctr" indent="0" marL="0">
+              <a:buNone/>
+            </a:pPr>
+            <a:r>
+              <a:rPr lang="en-US" sz="7200" b="1" dirty="0">
+                <a:solidFill>
+                  <a:srgbClr val="FFFFFF"/>
+                </a:solidFill>
+                <a:latin typeface="Poppins" pitchFamily="34" charset="0"/>
+                <a:ea typeface="Poppins" pitchFamily="34" charset="-122"/>
+                <a:cs typeface="Poppins" pitchFamily="34" charset="-120"/>
+              </a:rPr>
+              <a:t>$29.93</a:t>
+            </a:r>
+            <a:endParaRPr lang="en-US" sz="7200" dirty="0"/>
+          </a:p>
+        </p:txBody>
+      </p:sp>
+      <p:sp>
+        <p:nvSpPr>
+          <p:cNvPr id="14" name="Text 12"/>
+          <p:cNvSpPr txBox="1"/>
+          <p:nvPr/>
+        </p:nvSpPr>
+        <p:spPr>
+          <a:xfrm>
+            <a:off x="6656832" y="3886200"/>
+            <a:ext cx="5029200" cy="274320"/>
+          </a:xfrm>
+          <a:prstGeom prst="rect">
+            <a:avLst/>
+          </a:prstGeom>
+          <a:noFill/>
+          <a:ln/>
+        </p:spPr>
+        <p:txBody>
+          <a:bodyPr wrap="square" lIns="0" tIns="0" rIns="0" bIns="0" rtlCol="0" anchor="ctr"/>
+          <a:lstStyle/>
+          <a:p>
+            <a:pPr algn="ctr" indent="0" marL="0">
+              <a:buNone/>
+            </a:pPr>
+            <a:r>
+              <a:rPr lang="en-US" sz="1000" dirty="0">
+                <a:solidFill>
+                  <a:srgbClr val="7A8FA8"/>
+                </a:solidFill>
+                <a:latin typeface="Poppins" pitchFamily="34" charset="0"/>
+                <a:ea typeface="Poppins" pitchFamily="34" charset="-122"/>
+                <a:cs typeface="Poppins" pitchFamily="34" charset="-120"/>
+              </a:rPr>
+              <a:t>AVERAGE TRANSACTION VALUE</a:t>
+            </a:r>
+            <a:endParaRPr lang="en-US" sz="1000" dirty="0"/>
+          </a:p>
+        </p:txBody>
+      </p:sp>
+      <p:sp>
+        <p:nvSpPr>
+          <p:cNvPr id="15" name="Text 13"/>
+          <p:cNvSpPr txBox="1"/>
+          <p:nvPr/>
+        </p:nvSpPr>
+        <p:spPr>
+          <a:xfrm>
+            <a:off x="6656832" y="4251960"/>
+            <a:ext cx="5029200" cy="256032"/>
+          </a:xfrm>
+          <a:prstGeom prst="rect">
+            <a:avLst/>
+          </a:prstGeom>
+          <a:noFill/>
+          <a:ln/>
+        </p:spPr>
+        <p:txBody>
+          <a:bodyPr wrap="square" lIns="0" tIns="0" rIns="0" bIns="0" rtlCol="0" anchor="ctr"/>
+          <a:lstStyle/>
+          <a:p>
+            <a:pPr algn="ctr" indent="0" marL="0">
+              <a:buNone/>
+            </a:pPr>
+            <a:r>
+              <a:rPr lang="en-US" sz="1000" b="1" dirty="0">
+                <a:solidFill>
+                  <a:srgbClr val="E8541C"/>
+                </a:solidFill>
+                <a:latin typeface="Poppins" pitchFamily="34" charset="0"/>
+                <a:ea typeface="Poppins" pitchFamily="34" charset="-122"/>
+                <a:cs typeface="Poppins" pitchFamily="34" charset="-120"/>
+              </a:rPr>
+              <a:t>AUGUST 2026</a:t>
+            </a:r>
+            <a:endParaRPr lang="en-US" sz="1000" dirty="0"/>
+          </a:p>
+        </p:txBody>
+      </p:sp>
+      <p:sp>
+        <p:nvSpPr>
+          <p:cNvPr id="16" name="Shape 14"/>
+          <p:cNvSpPr/>
+          <p:nvPr/>
+        </p:nvSpPr>
+        <p:spPr>
+          <a:xfrm>
+            <a:off x="5413248" y="3017520"/>
+            <a:ext cx="1371600" cy="1371600"/>
+          </a:xfrm>
+          <a:prstGeom prst="ellipse">
+            <a:avLst/>
+          </a:prstGeom>
+          <a:solidFill>
+            <a:srgbClr val="0B1929"/>
+          </a:solidFill>
+          <a:ln w="25400">
+            <a:solidFill>
+              <a:srgbClr val="E8541C"/>
+            </a:solidFill>
+            <a:prstDash val="solid"/>
+          </a:ln>
+        </p:spPr>
+      </p:sp>
+      <p:sp>
+        <p:nvSpPr>
+          <p:cNvPr id="17" name="Text 15"/>
+          <p:cNvSpPr txBox="1"/>
+          <p:nvPr/>
+        </p:nvSpPr>
+        <p:spPr>
+          <a:xfrm>
+            <a:off x="5413248" y="3017520"/>
+            <a:ext cx="1371600" cy="1371600"/>
+          </a:xfrm>
+          <a:prstGeom prst="rect">
+            <a:avLst/>
+          </a:prstGeom>
+          <a:noFill/>
+          <a:ln/>
+        </p:spPr>
+        <p:txBody>
+          <a:bodyPr wrap="square" lIns="0" tIns="0" rIns="0" bIns="0" rtlCol="0" anchor="ctr"/>
+          <a:lstStyle/>
+          <a:p>
+            <a:pPr algn="ctr" indent="0" marL="0">
+              <a:buNone/>
+            </a:pPr>
+            <a:r>
+              <a:rPr lang="en-US" sz="2200" b="1" dirty="0">
+                <a:solidFill>
+                  <a:srgbClr val="E8541C"/>
+                </a:solidFill>
+                <a:latin typeface="Poppins" pitchFamily="34" charset="0"/>
+                <a:ea typeface="Poppins" pitchFamily="34" charset="-122"/>
+                <a:cs typeface="Poppins" pitchFamily="34" charset="-120"/>
+              </a:rPr>
+              <a:t>VS</a:t>
+            </a:r>
+            <a:endParaRPr lang="en-US" sz="2200" dirty="0"/>
+          </a:p>
+        </p:txBody>
+      </p:sp>
+      <p:sp>
+        <p:nvSpPr>
+          <p:cNvPr id="18" name="Text 16"/>
+          <p:cNvSpPr txBox="1"/>
+          <p:nvPr/>
+        </p:nvSpPr>
+        <p:spPr>
+          <a:xfrm>
+            <a:off x="457200" y="5715000"/>
+            <a:ext cx="11247120" cy="320040"/>
+          </a:xfrm>
+          <a:prstGeom prst="rect">
+            <a:avLst/>
+          </a:prstGeom>
+          <a:noFill/>
+          <a:ln/>
+        </p:spPr>
+        <p:txBody>
+          <a:bodyPr wrap="square" lIns="0" tIns="0" rIns="0" bIns="0" rtlCol="0" anchor="ctr"/>
+          <a:lstStyle/>
+          <a:p>
+            <a:pPr algn="ctr" indent="0" marL="0">
+              <a:buNone/>
+            </a:pPr>
+            <a:r>
+              <a:rPr lang="en-US" sz="1600" b="1" dirty="0">
+                <a:solidFill>
+                  <a:srgbClr val="7A8FA8"/>
+                </a:solidFill>
+                <a:latin typeface="Poppins" pitchFamily="34" charset="0"/>
+                <a:ea typeface="Poppins" pitchFamily="34" charset="-122"/>
+                <a:cs typeface="Poppins" pitchFamily="34" charset="-120"/>
+              </a:rPr>
+              <a:t>DIFFERENCE: $1.26  ·  4.2%</a:t>
+            </a:r>
+            <a:endParaRPr lang="en-US" sz="1600" dirty="0"/>
+          </a:p>
+        </p:txBody>
+      </p:sp>
+      <p:sp>
+        <p:nvSpPr>
+          <p:cNvPr id="19" name="Text 17"/>
+          <p:cNvSpPr txBox="1"/>
+          <p:nvPr/>
+        </p:nvSpPr>
+        <p:spPr>
+          <a:xfrm>
+            <a:off x="457200" y="6080760"/>
+            <a:ext cx="11247120" cy="274320"/>
+          </a:xfrm>
+          <a:prstGeom prst="rect">
+            <a:avLst/>
+          </a:prstGeom>
+          <a:noFill/>
+          <a:ln/>
+        </p:spPr>
+        <p:txBody>
+          <a:bodyPr wrap="square" lIns="0" tIns="0" rIns="0" bIns="0" rtlCol="0" anchor="ctr"/>
+          <a:lstStyle/>
+          <a:p>
+            <a:pPr algn="ctr" indent="0" marL="0">
+              <a:buNone/>
+            </a:pPr>
+            <a:r>
+              <a:rPr lang="en-US" sz="1400" dirty="0">
+                <a:solidFill>
+                  <a:srgbClr val="FFFFFF"/>
+                </a:solidFill>
+                <a:latin typeface="Poppins" pitchFamily="34" charset="0"/>
+                <a:ea typeface="Poppins" pitchFamily="34" charset="-122"/>
+                <a:cs typeface="Poppins" pitchFamily="34" charset="-120"/>
+              </a:rPr>
+              <a:t>Ads drive the decision to return — not basket size.</a:t>
+            </a:r>
+            <a:endParaRPr lang="en-US" sz="1400" dirty="0"/>
+          </a:p>
+        </p:txBody>
+      </p:sp>
+      <p:sp>
+        <p:nvSpPr>
+          <p:cNvPr id="20" name="Text 18"/>
+          <p:cNvSpPr txBox="1"/>
+          <p:nvPr/>
+        </p:nvSpPr>
+        <p:spPr>
+          <a:xfrm>
+            <a:off x="457200" y="6601968"/>
+            <a:ext cx="10058400" cy="201168"/>
+          </a:xfrm>
+          <a:prstGeom prst="rect">
+            <a:avLst/>
+          </a:prstGeom>
+          <a:noFill/>
+          <a:ln/>
+        </p:spPr>
+        <p:txBody>
+          <a:bodyPr wrap="square" lIns="0" tIns="0" rIns="0" bIns="0" rtlCol="0" anchor="ctr"/>
+          <a:lstStyle/>
+          <a:p>
+            <a:pPr indent="0" marL="0">
+              <a:buNone/>
+            </a:pPr>
+            <a:r>
+              <a:rPr lang="en-US" sz="750" dirty="0">
+                <a:solidFill>
+                  <a:srgbClr val="3A5A70"/>
+                </a:solidFill>
+                <a:latin typeface="Poppins" pitchFamily="34" charset="0"/>
+                <a:ea typeface="Poppins" pitchFamily="34" charset="-122"/>
+                <a:cs typeface="Poppins" pitchFamily="34" charset="-120"/>
+              </a:rPr>
+              <a:t>ATV measured via Meta holdout methodology. Source: Meta Ads Manager &amp; Redcat.</a:t>
+            </a:r>
+            <a:endParaRPr lang="en-US" sz="750" dirty="0"/>
+          </a:p>
+        </p:txBody>
+      </p:sp>
     </p:spTree>
   </p:cSld>
   <p:clrMapOvr>

</xml_diff>

<commit_message>
Add member return counts (346 vs 49) to ATV slide
Co-Authored-By: Claude Sonnet 4.6 <noreply@anthropic.com>
Claude-Session: https://claude.ai/code/session_0178o7F12XYkrs68ukbrnB6m
</commit_message>
<xml_diff>
--- a/GMS_Oakberry_ATV_Slide.pptx
+++ b/GMS_Oakberry_ATV_Slide.pptx
@@ -1049,11 +1049,11 @@
         <p:spPr>
           <a:xfrm>
             <a:off x="502920" y="1920240"/>
-            <a:ext cx="5029200" cy="3657600"/>
+            <a:ext cx="5029200" cy="4297680"/>
           </a:xfrm>
           <a:prstGeom prst="roundRect">
             <a:avLst>
-              <a:gd name="adj" fmla="val 3000"/>
+              <a:gd name="adj" fmla="val 2553"/>
             </a:avLst>
           </a:prstGeom>
           <a:solidFill>
@@ -1075,8 +1075,8 @@
         </p:nvSpPr>
         <p:spPr>
           <a:xfrm>
-            <a:off x="502920" y="2176272"/>
-            <a:ext cx="5029200" cy="274320"/>
+            <a:off x="502920" y="2121408"/>
+            <a:ext cx="5029200" cy="256032"/>
           </a:xfrm>
           <a:prstGeom prst="rect">
             <a:avLst/>
@@ -1092,7 +1092,7 @@
               <a:buNone/>
             </a:pPr>
             <a:r>
-              <a:rPr lang="en-US" sz="1200" b="1" dirty="0">
+              <a:rPr lang="en-US" sz="1100" b="1" dirty="0">
                 <a:solidFill>
                   <a:srgbClr val="7A8FA8"/>
                 </a:solidFill>
@@ -1102,7 +1102,7 @@
               </a:rPr>
               <a:t>AD-EXPOSED</a:t>
             </a:r>
-            <a:endParaRPr lang="en-US" sz="1200" dirty="0"/>
+            <a:endParaRPr lang="en-US" sz="1100" dirty="0"/>
           </a:p>
         </p:txBody>
       </p:sp>
@@ -1114,8 +1114,8 @@
         </p:nvSpPr>
         <p:spPr>
           <a:xfrm>
-            <a:off x="502920" y="2606040"/>
-            <a:ext cx="5029200" cy="1188720"/>
+            <a:off x="502920" y="2423160"/>
+            <a:ext cx="5029200" cy="1005840"/>
           </a:xfrm>
           <a:prstGeom prst="rect">
             <a:avLst/>
@@ -1131,17 +1131,17 @@
               <a:buNone/>
             </a:pPr>
             <a:r>
-              <a:rPr lang="en-US" sz="7200" b="1" dirty="0">
+              <a:rPr lang="en-US" sz="8000" b="1" dirty="0">
                 <a:solidFill>
-                  <a:srgbClr val="FFFFFF"/>
+                  <a:srgbClr val="E8541C"/>
                 </a:solidFill>
                 <a:latin typeface="Poppins" pitchFamily="34" charset="0"/>
                 <a:ea typeface="Poppins" pitchFamily="34" charset="-122"/>
                 <a:cs typeface="Poppins" pitchFamily="34" charset="-120"/>
               </a:rPr>
-              <a:t>$28.67</a:t>
-            </a:r>
-            <a:endParaRPr lang="en-US" sz="7200" dirty="0"/>
+              <a:t>346</a:t>
+            </a:r>
+            <a:endParaRPr lang="en-US" sz="8000" dirty="0"/>
           </a:p>
         </p:txBody>
       </p:sp>
@@ -1153,8 +1153,8 @@
         </p:nvSpPr>
         <p:spPr>
           <a:xfrm>
-            <a:off x="502920" y="3886200"/>
-            <a:ext cx="5029200" cy="274320"/>
+            <a:off x="502920" y="3493008"/>
+            <a:ext cx="5029200" cy="256032"/>
           </a:xfrm>
           <a:prstGeom prst="rect">
             <a:avLst/>
@@ -1178,7 +1178,7 @@
                 <a:ea typeface="Poppins" pitchFamily="34" charset="-122"/>
                 <a:cs typeface="Poppins" pitchFamily="34" charset="-120"/>
               </a:rPr>
-              <a:t>AVERAGE TRANSACTION VALUE</a:t>
+              <a:t>MEMBERS RETURNED</a:t>
             </a:r>
             <a:endParaRPr lang="en-US" sz="1000" dirty="0"/>
           </a:p>
@@ -1186,14 +1186,78 @@
       </p:sp>
       <p:sp>
         <p:nvSpPr>
-          <p:cNvPr id="10" name="Text 8"/>
+          <p:cNvPr id="10" name="Shape 8"/>
+          <p:cNvSpPr/>
+          <p:nvPr/>
+        </p:nvSpPr>
+        <p:spPr>
+          <a:xfrm>
+            <a:off x="1188720" y="3913632"/>
+            <a:ext cx="3657600" cy="27432"/>
+          </a:xfrm>
+          <a:prstGeom prst="rect">
+            <a:avLst/>
+          </a:prstGeom>
+          <a:solidFill>
+            <a:srgbClr val="1E3A55"/>
+          </a:solidFill>
+          <a:ln w="12700">
+            <a:solidFill>
+              <a:srgbClr val="1E3A55"/>
+            </a:solidFill>
+            <a:prstDash val="solid"/>
+          </a:ln>
+        </p:spPr>
+      </p:sp>
+      <p:sp>
+        <p:nvSpPr>
+          <p:cNvPr id="11" name="Text 9"/>
           <p:cNvSpPr txBox="1"/>
           <p:nvPr/>
         </p:nvSpPr>
         <p:spPr>
           <a:xfrm>
-            <a:off x="502920" y="4251960"/>
-            <a:ext cx="5029200" cy="256032"/>
+            <a:off x="502920" y="4041648"/>
+            <a:ext cx="5029200" cy="292608"/>
+          </a:xfrm>
+          <a:prstGeom prst="rect">
+            <a:avLst/>
+          </a:prstGeom>
+          <a:noFill/>
+          <a:ln/>
+        </p:spPr>
+        <p:txBody>
+          <a:bodyPr wrap="square" lIns="0" tIns="0" rIns="0" bIns="0" rtlCol="0" anchor="ctr"/>
+          <a:lstStyle/>
+          <a:p>
+            <a:pPr algn="ctr" indent="0" marL="0">
+              <a:buNone/>
+            </a:pPr>
+            <a:r>
+              <a:rPr lang="en-US" sz="1400" b="1" dirty="0">
+                <a:solidFill>
+                  <a:srgbClr val="FFFFFF"/>
+                </a:solidFill>
+                <a:latin typeface="Poppins" pitchFamily="34" charset="0"/>
+                <a:ea typeface="Poppins" pitchFamily="34" charset="-122"/>
+                <a:cs typeface="Poppins" pitchFamily="34" charset="-120"/>
+              </a:rPr>
+              <a:t>$28.67 ATV</a:t>
+            </a:r>
+            <a:endParaRPr lang="en-US" sz="1400" dirty="0"/>
+          </a:p>
+        </p:txBody>
+      </p:sp>
+      <p:sp>
+        <p:nvSpPr>
+          <p:cNvPr id="12" name="Text 10"/>
+          <p:cNvSpPr txBox="1"/>
+          <p:nvPr/>
+        </p:nvSpPr>
+        <p:spPr>
+          <a:xfrm>
+            <a:off x="502920" y="4434840"/>
+            <a:ext cx="5029200" cy="237744"/>
           </a:xfrm>
           <a:prstGeom prst="rect">
             <a:avLst/>
@@ -1225,18 +1289,18 @@
       </p:sp>
       <p:sp>
         <p:nvSpPr>
-          <p:cNvPr id="11" name="Shape 9"/>
+          <p:cNvPr id="13" name="Shape 11"/>
           <p:cNvSpPr/>
           <p:nvPr/>
         </p:nvSpPr>
         <p:spPr>
           <a:xfrm>
             <a:off x="6656832" y="1920240"/>
-            <a:ext cx="5029200" cy="3657600"/>
+            <a:ext cx="5029200" cy="4297680"/>
           </a:xfrm>
           <a:prstGeom prst="roundRect">
             <a:avLst>
-              <a:gd name="adj" fmla="val 3000"/>
+              <a:gd name="adj" fmla="val 2553"/>
             </a:avLst>
           </a:prstGeom>
           <a:solidFill>
@@ -1252,14 +1316,14 @@
       </p:sp>
       <p:sp>
         <p:nvSpPr>
-          <p:cNvPr id="12" name="Text 10"/>
+          <p:cNvPr id="14" name="Text 12"/>
           <p:cNvSpPr txBox="1"/>
           <p:nvPr/>
         </p:nvSpPr>
         <p:spPr>
           <a:xfrm>
-            <a:off x="6656832" y="2176272"/>
-            <a:ext cx="5029200" cy="274320"/>
+            <a:off x="6656832" y="2121408"/>
+            <a:ext cx="5029200" cy="256032"/>
           </a:xfrm>
           <a:prstGeom prst="rect">
             <a:avLst/>
@@ -1275,7 +1339,7 @@
               <a:buNone/>
             </a:pPr>
             <a:r>
-              <a:rPr lang="en-US" sz="1200" b="1" dirty="0">
+              <a:rPr lang="en-US" sz="1100" b="1" dirty="0">
                 <a:solidFill>
                   <a:srgbClr val="7A8FA8"/>
                 </a:solidFill>
@@ -1285,20 +1349,20 @@
               </a:rPr>
               <a:t>HOLDOUT GROUP</a:t>
             </a:r>
-            <a:endParaRPr lang="en-US" sz="1200" dirty="0"/>
-          </a:p>
-        </p:txBody>
-      </p:sp>
-      <p:sp>
-        <p:nvSpPr>
-          <p:cNvPr id="13" name="Text 11"/>
+            <a:endParaRPr lang="en-US" sz="1100" dirty="0"/>
+          </a:p>
+        </p:txBody>
+      </p:sp>
+      <p:sp>
+        <p:nvSpPr>
+          <p:cNvPr id="15" name="Text 13"/>
           <p:cNvSpPr txBox="1"/>
           <p:nvPr/>
         </p:nvSpPr>
         <p:spPr>
           <a:xfrm>
-            <a:off x="6656832" y="2606040"/>
-            <a:ext cx="5029200" cy="1188720"/>
+            <a:off x="6656832" y="2423160"/>
+            <a:ext cx="5029200" cy="1005840"/>
           </a:xfrm>
           <a:prstGeom prst="rect">
             <a:avLst/>
@@ -1314,7 +1378,7 @@
               <a:buNone/>
             </a:pPr>
             <a:r>
-              <a:rPr lang="en-US" sz="7200" b="1" dirty="0">
+              <a:rPr lang="en-US" sz="8000" b="1" dirty="0">
                 <a:solidFill>
                   <a:srgbClr val="FFFFFF"/>
                 </a:solidFill>
@@ -1322,22 +1386,22 @@
                 <a:ea typeface="Poppins" pitchFamily="34" charset="-122"/>
                 <a:cs typeface="Poppins" pitchFamily="34" charset="-120"/>
               </a:rPr>
-              <a:t>$29.93</a:t>
-            </a:r>
-            <a:endParaRPr lang="en-US" sz="7200" dirty="0"/>
-          </a:p>
-        </p:txBody>
-      </p:sp>
-      <p:sp>
-        <p:nvSpPr>
-          <p:cNvPr id="14" name="Text 12"/>
+              <a:t>49</a:t>
+            </a:r>
+            <a:endParaRPr lang="en-US" sz="8000" dirty="0"/>
+          </a:p>
+        </p:txBody>
+      </p:sp>
+      <p:sp>
+        <p:nvSpPr>
+          <p:cNvPr id="16" name="Text 14"/>
           <p:cNvSpPr txBox="1"/>
           <p:nvPr/>
         </p:nvSpPr>
         <p:spPr>
           <a:xfrm>
-            <a:off x="6656832" y="3886200"/>
-            <a:ext cx="5029200" cy="274320"/>
+            <a:off x="6656832" y="3493008"/>
+            <a:ext cx="5029200" cy="256032"/>
           </a:xfrm>
           <a:prstGeom prst="rect">
             <a:avLst/>
@@ -1361,7 +1425,7 @@
                 <a:ea typeface="Poppins" pitchFamily="34" charset="-122"/>
                 <a:cs typeface="Poppins" pitchFamily="34" charset="-120"/>
               </a:rPr>
-              <a:t>AVERAGE TRANSACTION VALUE</a:t>
+              <a:t>MEMBERS RETURNED</a:t>
             </a:r>
             <a:endParaRPr lang="en-US" sz="1000" dirty="0"/>
           </a:p>
@@ -1369,14 +1433,78 @@
       </p:sp>
       <p:sp>
         <p:nvSpPr>
-          <p:cNvPr id="15" name="Text 13"/>
+          <p:cNvPr id="17" name="Shape 15"/>
+          <p:cNvSpPr/>
+          <p:nvPr/>
+        </p:nvSpPr>
+        <p:spPr>
+          <a:xfrm>
+            <a:off x="7342632" y="3913632"/>
+            <a:ext cx="3657600" cy="27432"/>
+          </a:xfrm>
+          <a:prstGeom prst="rect">
+            <a:avLst/>
+          </a:prstGeom>
+          <a:solidFill>
+            <a:srgbClr val="1E3A55"/>
+          </a:solidFill>
+          <a:ln w="12700">
+            <a:solidFill>
+              <a:srgbClr val="1E3A55"/>
+            </a:solidFill>
+            <a:prstDash val="solid"/>
+          </a:ln>
+        </p:spPr>
+      </p:sp>
+      <p:sp>
+        <p:nvSpPr>
+          <p:cNvPr id="18" name="Text 16"/>
           <p:cNvSpPr txBox="1"/>
           <p:nvPr/>
         </p:nvSpPr>
         <p:spPr>
           <a:xfrm>
-            <a:off x="6656832" y="4251960"/>
-            <a:ext cx="5029200" cy="256032"/>
+            <a:off x="6656832" y="4041648"/>
+            <a:ext cx="5029200" cy="292608"/>
+          </a:xfrm>
+          <a:prstGeom prst="rect">
+            <a:avLst/>
+          </a:prstGeom>
+          <a:noFill/>
+          <a:ln/>
+        </p:spPr>
+        <p:txBody>
+          <a:bodyPr wrap="square" lIns="0" tIns="0" rIns="0" bIns="0" rtlCol="0" anchor="ctr"/>
+          <a:lstStyle/>
+          <a:p>
+            <a:pPr algn="ctr" indent="0" marL="0">
+              <a:buNone/>
+            </a:pPr>
+            <a:r>
+              <a:rPr lang="en-US" sz="1400" b="1" dirty="0">
+                <a:solidFill>
+                  <a:srgbClr val="FFFFFF"/>
+                </a:solidFill>
+                <a:latin typeface="Poppins" pitchFamily="34" charset="0"/>
+                <a:ea typeface="Poppins" pitchFamily="34" charset="-122"/>
+                <a:cs typeface="Poppins" pitchFamily="34" charset="-120"/>
+              </a:rPr>
+              <a:t>$29.93 ATV</a:t>
+            </a:r>
+            <a:endParaRPr lang="en-US" sz="1400" dirty="0"/>
+          </a:p>
+        </p:txBody>
+      </p:sp>
+      <p:sp>
+        <p:nvSpPr>
+          <p:cNvPr id="19" name="Text 17"/>
+          <p:cNvSpPr txBox="1"/>
+          <p:nvPr/>
+        </p:nvSpPr>
+        <p:spPr>
+          <a:xfrm>
+            <a:off x="6656832" y="4434840"/>
+            <a:ext cx="5029200" cy="237744"/>
           </a:xfrm>
           <a:prstGeom prst="rect">
             <a:avLst/>
@@ -1408,7 +1536,7 @@
       </p:sp>
       <p:sp>
         <p:nvSpPr>
-          <p:cNvPr id="16" name="Shape 14"/>
+          <p:cNvPr id="20" name="Shape 18"/>
           <p:cNvSpPr/>
           <p:nvPr/>
         </p:nvSpPr>
@@ -1433,7 +1561,7 @@
       </p:sp>
       <p:sp>
         <p:nvSpPr>
-          <p:cNvPr id="17" name="Text 15"/>
+          <p:cNvPr id="21" name="Text 19"/>
           <p:cNvSpPr txBox="1"/>
           <p:nvPr/>
         </p:nvSpPr>
@@ -1472,13 +1600,13 @@
       </p:sp>
       <p:sp>
         <p:nvSpPr>
-          <p:cNvPr id="18" name="Text 16"/>
+          <p:cNvPr id="22" name="Text 20"/>
           <p:cNvSpPr txBox="1"/>
           <p:nvPr/>
         </p:nvSpPr>
         <p:spPr>
           <a:xfrm>
-            <a:off x="457200" y="5715000"/>
+            <a:off x="457200" y="6382512"/>
             <a:ext cx="11247120" cy="320040"/>
           </a:xfrm>
           <a:prstGeom prst="rect">
@@ -1495,29 +1623,29 @@
               <a:buNone/>
             </a:pPr>
             <a:r>
-              <a:rPr lang="en-US" sz="1600" b="1" dirty="0">
+              <a:rPr lang="en-US" sz="1300" b="1" dirty="0">
                 <a:solidFill>
-                  <a:srgbClr val="7A8FA8"/>
+                  <a:srgbClr val="E8541C"/>
                 </a:solidFill>
                 <a:latin typeface="Poppins" pitchFamily="34" charset="0"/>
                 <a:ea typeface="Poppins" pitchFamily="34" charset="-122"/>
                 <a:cs typeface="Poppins" pitchFamily="34" charset="-120"/>
               </a:rPr>
-              <a:t>DIFFERENCE: $1.26  ·  4.2%</a:t>
-            </a:r>
-            <a:endParaRPr lang="en-US" sz="1600" dirty="0"/>
-          </a:p>
-        </p:txBody>
-      </p:sp>
-      <p:sp>
-        <p:nvSpPr>
-          <p:cNvPr id="19" name="Text 17"/>
+              <a:t>7× MORE MEMBERS RETURNED  ·  ATV NEARLY IDENTICAL</a:t>
+            </a:r>
+            <a:endParaRPr lang="en-US" sz="1300" dirty="0"/>
+          </a:p>
+        </p:txBody>
+      </p:sp>
+      <p:sp>
+        <p:nvSpPr>
+          <p:cNvPr id="23" name="Text 21"/>
           <p:cNvSpPr txBox="1"/>
           <p:nvPr/>
         </p:nvSpPr>
         <p:spPr>
           <a:xfrm>
-            <a:off x="457200" y="6080760"/>
+            <a:off x="457200" y="6016752"/>
             <a:ext cx="11247120" cy="274320"/>
           </a:xfrm>
           <a:prstGeom prst="rect">
@@ -1534,7 +1662,7 @@
               <a:buNone/>
             </a:pPr>
             <a:r>
-              <a:rPr lang="en-US" sz="1400" dirty="0">
+              <a:rPr lang="en-US" sz="1300" dirty="0">
                 <a:solidFill>
                   <a:srgbClr val="FFFFFF"/>
                 </a:solidFill>
@@ -1542,15 +1670,15 @@
                 <a:ea typeface="Poppins" pitchFamily="34" charset="-122"/>
                 <a:cs typeface="Poppins" pitchFamily="34" charset="-120"/>
               </a:rPr>
-              <a:t>Ads drive the decision to return — not basket size.</a:t>
-            </a:r>
-            <a:endParaRPr lang="en-US" sz="1400" dirty="0"/>
-          </a:p>
-        </p:txBody>
-      </p:sp>
-      <p:sp>
-        <p:nvSpPr>
-          <p:cNvPr id="20" name="Text 18"/>
+              <a:t>Ads drove the decision to return — not basket size.</a:t>
+            </a:r>
+            <a:endParaRPr lang="en-US" sz="1300" dirty="0"/>
+          </a:p>
+        </p:txBody>
+      </p:sp>
+      <p:sp>
+        <p:nvSpPr>
+          <p:cNvPr id="24" name="Text 22"/>
           <p:cNvSpPr txBox="1"/>
           <p:nvPr/>
         </p:nvSpPr>

</xml_diff>

<commit_message>
Restore ATVs as hero stats, member counts as secondary
Co-Authored-By: Claude Sonnet 4.6 <noreply@anthropic.com>
Claude-Session: https://claude.ai/code/session_0178o7F12XYkrs68ukbrnB6m
</commit_message>
<xml_diff>
--- a/GMS_Oakberry_ATV_Slide.pptx
+++ b/GMS_Oakberry_ATV_Slide.pptx
@@ -1139,7 +1139,7 @@
                 <a:ea typeface="Poppins" pitchFamily="34" charset="-122"/>
                 <a:cs typeface="Poppins" pitchFamily="34" charset="-120"/>
               </a:rPr>
-              <a:t>346</a:t>
+              <a:t>$28.67</a:t>
             </a:r>
             <a:endParaRPr lang="en-US" sz="8000" dirty="0"/>
           </a:p>
@@ -1178,7 +1178,7 @@
                 <a:ea typeface="Poppins" pitchFamily="34" charset="-122"/>
                 <a:cs typeface="Poppins" pitchFamily="34" charset="-120"/>
               </a:rPr>
-              <a:t>MEMBERS RETURNED</a:t>
+              <a:t>AVERAGE TRANSACTION VALUE</a:t>
             </a:r>
             <a:endParaRPr lang="en-US" sz="1000" dirty="0"/>
           </a:p>
@@ -1234,7 +1234,7 @@
               <a:buNone/>
             </a:pPr>
             <a:r>
-              <a:rPr lang="en-US" sz="1400" b="1" dirty="0">
+              <a:rPr lang="en-US" sz="1300" b="1" dirty="0">
                 <a:solidFill>
                   <a:srgbClr val="FFFFFF"/>
                 </a:solidFill>
@@ -1242,9 +1242,9 @@
                 <a:ea typeface="Poppins" pitchFamily="34" charset="-122"/>
                 <a:cs typeface="Poppins" pitchFamily="34" charset="-120"/>
               </a:rPr>
-              <a:t>$28.67 ATV</a:t>
-            </a:r>
-            <a:endParaRPr lang="en-US" sz="1400" dirty="0"/>
+              <a:t>346 members returned</a:t>
+            </a:r>
+            <a:endParaRPr lang="en-US" sz="1300" dirty="0"/>
           </a:p>
         </p:txBody>
       </p:sp>
@@ -1386,7 +1386,7 @@
                 <a:ea typeface="Poppins" pitchFamily="34" charset="-122"/>
                 <a:cs typeface="Poppins" pitchFamily="34" charset="-120"/>
               </a:rPr>
-              <a:t>49</a:t>
+              <a:t>$29.93</a:t>
             </a:r>
             <a:endParaRPr lang="en-US" sz="8000" dirty="0"/>
           </a:p>
@@ -1425,7 +1425,7 @@
                 <a:ea typeface="Poppins" pitchFamily="34" charset="-122"/>
                 <a:cs typeface="Poppins" pitchFamily="34" charset="-120"/>
               </a:rPr>
-              <a:t>MEMBERS RETURNED</a:t>
+              <a:t>AVERAGE TRANSACTION VALUE</a:t>
             </a:r>
             <a:endParaRPr lang="en-US" sz="1000" dirty="0"/>
           </a:p>
@@ -1481,7 +1481,7 @@
               <a:buNone/>
             </a:pPr>
             <a:r>
-              <a:rPr lang="en-US" sz="1400" b="1" dirty="0">
+              <a:rPr lang="en-US" sz="1300" b="1" dirty="0">
                 <a:solidFill>
                   <a:srgbClr val="FFFFFF"/>
                 </a:solidFill>
@@ -1489,9 +1489,9 @@
                 <a:ea typeface="Poppins" pitchFamily="34" charset="-122"/>
                 <a:cs typeface="Poppins" pitchFamily="34" charset="-120"/>
               </a:rPr>
-              <a:t>$29.93 ATV</a:t>
-            </a:r>
-            <a:endParaRPr lang="en-US" sz="1400" dirty="0"/>
+              <a:t>49 members returned</a:t>
+            </a:r>
+            <a:endParaRPr lang="en-US" sz="1300" dirty="0"/>
           </a:p>
         </p:txBody>
       </p:sp>
@@ -1606,7 +1606,7 @@
         </p:nvSpPr>
         <p:spPr>
           <a:xfrm>
-            <a:off x="457200" y="6382512"/>
+            <a:off x="457200" y="6016752"/>
             <a:ext cx="11247120" cy="320040"/>
           </a:xfrm>
           <a:prstGeom prst="rect">
@@ -1623,17 +1623,17 @@
               <a:buNone/>
             </a:pPr>
             <a:r>
-              <a:rPr lang="en-US" sz="1300" b="1" dirty="0">
+              <a:rPr lang="en-US" sz="1400" b="1" dirty="0">
                 <a:solidFill>
-                  <a:srgbClr val="E8541C"/>
+                  <a:srgbClr val="7A8FA8"/>
                 </a:solidFill>
                 <a:latin typeface="Poppins" pitchFamily="34" charset="0"/>
                 <a:ea typeface="Poppins" pitchFamily="34" charset="-122"/>
                 <a:cs typeface="Poppins" pitchFamily="34" charset="-120"/>
               </a:rPr>
-              <a:t>7× MORE MEMBERS RETURNED  ·  ATV NEARLY IDENTICAL</a:t>
-            </a:r>
-            <a:endParaRPr lang="en-US" sz="1300" dirty="0"/>
+              <a:t>DIFFERENCE: $1.26  ·  4.2%</a:t>
+            </a:r>
+            <a:endParaRPr lang="en-US" sz="1400" dirty="0"/>
           </a:p>
         </p:txBody>
       </p:sp>
@@ -1645,7 +1645,7 @@
         </p:nvSpPr>
         <p:spPr>
           <a:xfrm>
-            <a:off x="457200" y="6016752"/>
+            <a:off x="457200" y="6382512"/>
             <a:ext cx="11247120" cy="274320"/>
           </a:xfrm>
           <a:prstGeom prst="rect">

</xml_diff>